<commit_message>
docs: de-overclaim benefits leadership deck (remove 'adjudication' framing, match P0-10 repositioning) + README CI update
Cover + workflow-slide titles said 'Public-Benefits Adjudication' / 'adjudicating a SNAP application' — the agent-as-decider framing P0-10 removed from the other three decks. Retitled to neutral 'Public-Benefits Eligibility' / 'determining eligibility from a SNAP/Medicaid application'; the correct 'never self-adjudicates' framing stays. Regenerated the .pptx.
</commit_message>
<xml_diff>
--- a/docs/Benefits-AgentCore-Leadership.pptx
+++ b/docs/Benefits-AgentCore-Leadership.pptx
@@ -2118,7 +2118,7 @@
                 <a:ea typeface="Cambria" pitchFamily="34" charset="-122"/>
                 <a:cs typeface="Cambria" pitchFamily="34" charset="-120"/>
               </a:rPr>
-              <a:t>Proven in Public-Benefits Adjudication</a:t>
+              <a:t>Proven in Public-Benefits Eligibility</a:t>
             </a:r>
             <a:endParaRPr lang="en-US" sz="4000" dirty="0"/>
           </a:p>
@@ -10908,7 +10908,7 @@
                 <a:ea typeface="Cambria" pitchFamily="34" charset="-122"/>
                 <a:cs typeface="Cambria" pitchFamily="34" charset="-120"/>
               </a:rPr>
-              <a:t>Benefits eligibility: adjudicating a SNAP / Medicaid application</a:t>
+              <a:t>Benefits eligibility: determining eligibility from a SNAP / Medicaid application</a:t>
             </a:r>
             <a:endParaRPr lang="en-US" sz="2700" dirty="0"/>
           </a:p>

</xml_diff>